<commit_message>
docs(submission): roadmap card names the production gaps
Co-Authored-By: Claude Fable 5.1 <noreply@anthropic.com>
</commit_message>
<xml_diff>
--- a/docs/submission/Kirana-Mitra-AI-Builder-Cup-Submission.pptx
+++ b/docs/submission/Kirana-Mitra-AI-Builder-Cup-Submission.pptx
@@ -779,7 +779,7 @@
           <a:p>
             <a:r>
               <a:rPr lang="en-US" dirty="0"/>
-              <a:t>The top row is the mentor's production roadmap: godown, offline model, end-to-end readiness and cost reduction. The bottom row is what we deliberately left out of the MVP.</a:t>
+              <a:t>The top row is the mentor's production roadmap: godown, offline model, and the five concrete gaps between the demo and production. The bottom row is what we deliberately left out of the MVP.</a:t>
             </a:r>
             <a:endParaRPr lang="en-US" dirty="0"/>
           </a:p>
@@ -4838,7 +4838,7 @@
       </p:sp>
       <p:pic>
         <p:nvPicPr>
-          <p:cNvPr id="12" name="anim Production-ready, end to end icon" descr="preencoded.png">    </p:cNvPr>
+          <p:cNvPr id="12" name="anim Production gaps to close icon" descr="preencoded.png">    </p:cNvPr>
           <p:cNvPicPr>
             <a:picLocks noChangeAspect="1"/>
           </p:cNvPicPr>
@@ -4862,7 +4862,7 @@
       </p:pic>
       <p:sp>
         <p:nvSpPr>
-          <p:cNvPr id="13" name="anim Production-ready, end to end"/>
+          <p:cNvPr id="13" name="anim Production gaps to close"/>
           <p:cNvSpPr txBox="1"/>
           <p:nvPr/>
         </p:nvSpPr>
@@ -4890,7 +4890,7 @@
                   <a:srgbClr val="1A1A1A"/>
                 </a:solidFill>
               </a:rPr>
-              <a:t>Production-ready, end to end</a:t>
+              <a:t>Production gaps to close</a:t>
             </a:r>
             <a:endParaRPr lang="en-US" sz="1200" dirty="0"/>
           </a:p>
@@ -4898,7 +4898,7 @@
       </p:sp>
       <p:sp>
         <p:nvSpPr>
-          <p:cNvPr id="14" name="anim Production-ready, end to end text"/>
+          <p:cNvPr id="14" name="anim Production gaps to close text"/>
           <p:cNvSpPr txBox="1"/>
           <p:nvPr/>
         </p:nvSpPr>
@@ -4926,7 +4926,7 @@
                   <a:srgbClr val="1A1A1A"/>
                 </a:solidFill>
               </a:rPr>
-              <a:t>Cloud SQL persistence, sign-in, ADK multi-agent orchestration, Vertex AI Search catalogue matching, monitoring and cost caps.</a:t>
+              <a:t>Persistence (Cloud SQL, today in memory) · sign-in and per-shop access · real pilot sales and shelves · monitoring, rate limits and Gemini cost caps · native review of the 22 languages.</a:t>
             </a:r>
             <a:endParaRPr lang="en-US" sz="1000" dirty="0"/>
           </a:p>
@@ -4961,7 +4961,7 @@
       </p:sp>
       <p:pic>
         <p:nvPicPr>
-          <p:cNvPr id="16" name="anim 22-language app, reviewed icon" descr="preencoded.png">    </p:cNvPr>
+          <p:cNvPr id="16" name="anim 22 languages in the app icon" descr="preencoded.png">    </p:cNvPr>
           <p:cNvPicPr>
             <a:picLocks noChangeAspect="1"/>
           </p:cNvPicPr>
@@ -4985,7 +4985,7 @@
       </p:pic>
       <p:sp>
         <p:nvSpPr>
-          <p:cNvPr id="17" name="anim 22-language app, reviewed"/>
+          <p:cNvPr id="17" name="anim 22 languages in the app"/>
           <p:cNvSpPr txBox="1"/>
           <p:nvPr/>
         </p:nvSpPr>
@@ -5013,7 +5013,7 @@
                   <a:srgbClr val="1A1A1A"/>
                 </a:solidFill>
               </a:rPr>
-              <a:t>22-language app, reviewed</a:t>
+              <a:t>22 languages in the app</a:t>
             </a:r>
             <a:endParaRPr lang="en-US" sz="1200" dirty="0"/>
           </a:p>
@@ -5021,7 +5021,7 @@
       </p:sp>
       <p:sp>
         <p:nvSpPr>
-          <p:cNvPr id="18" name="anim 22-language app, reviewed text"/>
+          <p:cNvPr id="18" name="anim 22 languages in the app text"/>
           <p:cNvSpPr txBox="1"/>
           <p:nvPr/>
         </p:nvSpPr>
@@ -5049,7 +5049,7 @@
                   <a:srgbClr val="1A1A1A"/>
                 </a:solidFill>
               </a:rPr>
-              <a:t>Backend already replies in all 22; UI strings generated with Gemini need native-speaker review before launch.</a:t>
+              <a:t>Backend already replies in all 22; the generated UI strings ship language by language after native-speaker review, largest eight first.</a:t>
             </a:r>
             <a:endParaRPr lang="en-US" sz="1000" dirty="0"/>
           </a:p>

</xml_diff>

<commit_message>
docs(submission): Firestore live in deck and description; final submission pack
Co-Authored-By: Claude Fable 5.1 <noreply@anthropic.com>
</commit_message>
<xml_diff>
--- a/docs/submission/Kirana-Mitra-AI-Builder-Cup-Submission.pptx
+++ b/docs/submission/Kirana-Mitra-AI-Builder-Cup-Submission.pptx
@@ -4926,7 +4926,7 @@
                   <a:srgbClr val="1A1A1A"/>
                 </a:solidFill>
               </a:rPr>
-              <a:t>Persistence (Cloud SQL, today in memory) · sign-in and per-shop access · real pilot sales and shelves · monitoring, rate limits and Gemini cost caps · native review of the 22 languages.</a:t>
+              <a:t>Sign-in and per-shop access (Firebase Auth) · real pilot sales and shelves · monitoring, rate limits and Gemini cost caps · backups and Firestore security rules · native review of the 22 languages.</a:t>
             </a:r>
             <a:endParaRPr lang="en-US" sz="1000" dirty="0"/>
           </a:p>
@@ -13816,7 +13816,7 @@
                   <a:srgbClr val="1A1A1A"/>
                 </a:solidFill>
               </a:rPr>
-              <a:t>Flutter web app (also Android) · camera · mic · 22 languages</a:t>
+              <a:t>Flutter web app on Firebase Hosting (also Android) · camera · mic</a:t>
             </a:r>
             <a:endParaRPr lang="en-US" sz="850" dirty="0"/>
           </a:p>
@@ -14339,7 +14339,7 @@
                   <a:srgbClr val="1A1A1A"/>
                 </a:solidFill>
               </a:rPr>
-              <a:t>Cloud Storage</a:t>
+              <a:t>Firebase Hosting + Cloud Storage</a:t>
             </a:r>
             <a:endParaRPr lang="en-US" sz="1000" dirty="0"/>
           </a:p>
@@ -14375,7 +14375,7 @@
                   <a:srgbClr val="1A1A1A"/>
                 </a:solidFill>
               </a:rPr>
-              <a:t>Hosts the web app; shelf photos and voice audio</a:t>
+              <a:t>Serves the Flutter web app; shelf photos and voice audio</a:t>
             </a:r>
             <a:endParaRPr lang="en-US" sz="800" dirty="0"/>
           </a:p>
@@ -14467,11 +14467,11 @@
             </a:avLst>
           </a:prstGeom>
           <a:solidFill>
-            <a:srgbClr val="F7F7F7"/>
+            <a:srgbClr val="F3EFEA"/>
           </a:solidFill>
           <a:ln w="12700">
             <a:solidFill>
-              <a:srgbClr val="F7F7F7"/>
+              <a:srgbClr val="F3EFEA"/>
             </a:solidFill>
             <a:prstDash val="solid"/>
           </a:ln>
@@ -14504,10 +14504,10 @@
             <a:r>
               <a:rPr lang="en-US" sz="1000" b="1" dirty="0">
                 <a:solidFill>
-                  <a:srgbClr val="5F5F5F"/>
+                  <a:srgbClr val="1A1A1A"/>
                 </a:solidFill>
               </a:rPr>
-              <a:t>Cloud SQL (roadmap)</a:t>
+              <a:t>Firestore</a:t>
             </a:r>
             <a:endParaRPr lang="en-US" sz="1000" dirty="0"/>
           </a:p>
@@ -14540,10 +14540,10 @@
             <a:r>
               <a:rPr lang="en-US" sz="800" dirty="0">
                 <a:solidFill>
-                  <a:srgbClr val="5F5F5F"/>
+                  <a:srgbClr val="1A1A1A"/>
                 </a:solidFill>
               </a:rPr>
-              <a:t>Shops, items and stock today live in memory on Cloud Run; persistence is the first production step</a:t>
+              <a:t>Shops, items, stock, messages, orders and feedback as documents; stock updates and undo in transactions</a:t>
             </a:r>
             <a:endParaRPr lang="en-US" sz="800" dirty="0"/>
           </a:p>
@@ -16325,7 +16325,7 @@
                           <a:ea typeface="Arial" pitchFamily="34" charset="-122"/>
                           <a:cs typeface="Arial" pitchFamily="34" charset="-120"/>
                         </a:rPr>
-                        <a:t>Storage</a:t>
+                        <a:t>Database</a:t>
                       </a:r>
                       <a:endParaRPr lang="en-US" sz="900" dirty="0">
                         <a:latin typeface="Arial" charset="0"/>
@@ -16393,7 +16393,7 @@
                           <a:ea typeface="Arial" pitchFamily="34" charset="-122"/>
                           <a:cs typeface="Arial" pitchFamily="34" charset="-120"/>
                         </a:rPr>
-                        <a:t>Cloud Storage</a:t>
+                        <a:t>Firestore (Native mode, asia-south1)</a:t>
                       </a:r>
                       <a:endParaRPr lang="en-US" sz="900" dirty="0">
                         <a:latin typeface="Arial" charset="0"/>
@@ -16461,7 +16461,7 @@
                           <a:ea typeface="Arial" pitchFamily="34" charset="-122"/>
                           <a:cs typeface="Arial" pitchFamily="34" charset="-120"/>
                         </a:rPr>
-                        <a:t>Hosts the Flutter web build; photos and audio</a:t>
+                        <a:t>Shops, items, stock, messages, orders and feedback; transactional stock updates and undo</a:t>
                       </a:r>
                       <a:endParaRPr lang="en-US" sz="900" dirty="0">
                         <a:latin typeface="Arial" charset="0"/>
@@ -16509,6 +16509,212 @@
                     </a:lnB>
                     <a:solidFill>
                       <a:srgbClr val="FAF7F3"/>
+                    </a:solidFill>
+                  </a:tcPr>
+                </a:tc>
+              </a:tr>
+              <a:tr h="384048">
+                <a:tc>
+                  <a:txBody>
+                    <a:bodyPr/>
+                    <a:lstStyle/>
+                    <a:p>
+                      <a:pPr indent="0" marL="0">
+                        <a:buNone/>
+                      </a:pPr>
+                      <a:r>
+                        <a:rPr lang="en-US" sz="900" b="1" dirty="0">
+                          <a:solidFill>
+                            <a:srgbClr val="1A1A1A"/>
+                          </a:solidFill>
+                          <a:latin typeface="Arial" pitchFamily="34" charset="0"/>
+                          <a:ea typeface="Arial" pitchFamily="34" charset="-122"/>
+                          <a:cs typeface="Arial" pitchFamily="34" charset="-120"/>
+                        </a:rPr>
+                        <a:t>Hosting / storage</a:t>
+                      </a:r>
+                      <a:endParaRPr lang="en-US" sz="900" dirty="0">
+                        <a:latin typeface="Arial" charset="0"/>
+                        <a:ea typeface="Arial" charset="0"/>
+                        <a:cs typeface="Arial" charset="0"/>
+                      </a:endParaRPr>
+                    </a:p>
+                  </a:txBody>
+                  <a:tcPr marL="45720" marR="45720" marT="45720" marB="45720" anchor="ctr">
+                    <a:lnL w="6350" cap="flat" cmpd="sng" algn="ctr">
+                      <a:solidFill>
+                        <a:srgbClr val="E3DDD4"/>
+                      </a:solidFill>
+                      <a:prstDash val="solid"/>
+                      <a:round/>
+                      <a:headEnd type="none" w="med" len="med"/>
+                      <a:tailEnd type="none" w="med" len="med"/>
+                    </a:lnL>
+                    <a:lnR w="6350" cap="flat" cmpd="sng" algn="ctr">
+                      <a:solidFill>
+                        <a:srgbClr val="E3DDD4"/>
+                      </a:solidFill>
+                      <a:prstDash val="solid"/>
+                      <a:round/>
+                      <a:headEnd type="none" w="med" len="med"/>
+                      <a:tailEnd type="none" w="med" len="med"/>
+                    </a:lnR>
+                    <a:lnT w="6350" cap="flat" cmpd="sng" algn="ctr">
+                      <a:solidFill>
+                        <a:srgbClr val="E3DDD4"/>
+                      </a:solidFill>
+                      <a:prstDash val="solid"/>
+                      <a:round/>
+                      <a:headEnd type="none" w="med" len="med"/>
+                      <a:tailEnd type="none" w="med" len="med"/>
+                    </a:lnT>
+                    <a:lnB w="6350" cap="flat" cmpd="sng" algn="ctr">
+                      <a:solidFill>
+                        <a:srgbClr val="E3DDD4"/>
+                      </a:solidFill>
+                      <a:prstDash val="solid"/>
+                      <a:round/>
+                      <a:headEnd type="none" w="med" len="med"/>
+                      <a:tailEnd type="none" w="med" len="med"/>
+                    </a:lnB>
+                    <a:solidFill>
+                      <a:srgbClr val="FFFFFF"/>
+                    </a:solidFill>
+                  </a:tcPr>
+                </a:tc>
+                <a:tc>
+                  <a:txBody>
+                    <a:bodyPr/>
+                    <a:lstStyle/>
+                    <a:p>
+                      <a:pPr indent="0" marL="0">
+                        <a:buNone/>
+                      </a:pPr>
+                      <a:r>
+                        <a:rPr lang="en-US" sz="900" dirty="0">
+                          <a:solidFill>
+                            <a:srgbClr val="1A1A1A"/>
+                          </a:solidFill>
+                          <a:latin typeface="Arial" pitchFamily="34" charset="0"/>
+                          <a:ea typeface="Arial" pitchFamily="34" charset="-122"/>
+                          <a:cs typeface="Arial" pitchFamily="34" charset="-120"/>
+                        </a:rPr>
+                        <a:t>Firebase Hosting, Cloud Storage</a:t>
+                      </a:r>
+                      <a:endParaRPr lang="en-US" sz="900" dirty="0">
+                        <a:latin typeface="Arial" charset="0"/>
+                        <a:ea typeface="Arial" charset="0"/>
+                        <a:cs typeface="Arial" charset="0"/>
+                      </a:endParaRPr>
+                    </a:p>
+                  </a:txBody>
+                  <a:tcPr marL="45720" marR="45720" marT="45720" marB="45720" anchor="ctr">
+                    <a:lnL w="6350" cap="flat" cmpd="sng" algn="ctr">
+                      <a:solidFill>
+                        <a:srgbClr val="E3DDD4"/>
+                      </a:solidFill>
+                      <a:prstDash val="solid"/>
+                      <a:round/>
+                      <a:headEnd type="none" w="med" len="med"/>
+                      <a:tailEnd type="none" w="med" len="med"/>
+                    </a:lnL>
+                    <a:lnR w="6350" cap="flat" cmpd="sng" algn="ctr">
+                      <a:solidFill>
+                        <a:srgbClr val="E3DDD4"/>
+                      </a:solidFill>
+                      <a:prstDash val="solid"/>
+                      <a:round/>
+                      <a:headEnd type="none" w="med" len="med"/>
+                      <a:tailEnd type="none" w="med" len="med"/>
+                    </a:lnR>
+                    <a:lnT w="6350" cap="flat" cmpd="sng" algn="ctr">
+                      <a:solidFill>
+                        <a:srgbClr val="E3DDD4"/>
+                      </a:solidFill>
+                      <a:prstDash val="solid"/>
+                      <a:round/>
+                      <a:headEnd type="none" w="med" len="med"/>
+                      <a:tailEnd type="none" w="med" len="med"/>
+                    </a:lnT>
+                    <a:lnB w="6350" cap="flat" cmpd="sng" algn="ctr">
+                      <a:solidFill>
+                        <a:srgbClr val="E3DDD4"/>
+                      </a:solidFill>
+                      <a:prstDash val="solid"/>
+                      <a:round/>
+                      <a:headEnd type="none" w="med" len="med"/>
+                      <a:tailEnd type="none" w="med" len="med"/>
+                    </a:lnB>
+                    <a:solidFill>
+                      <a:srgbClr val="FFFFFF"/>
+                    </a:solidFill>
+                  </a:tcPr>
+                </a:tc>
+                <a:tc>
+                  <a:txBody>
+                    <a:bodyPr/>
+                    <a:lstStyle/>
+                    <a:p>
+                      <a:pPr indent="0" marL="0">
+                        <a:buNone/>
+                      </a:pPr>
+                      <a:r>
+                        <a:rPr lang="en-US" sz="900" dirty="0">
+                          <a:solidFill>
+                            <a:srgbClr val="1A1A1A"/>
+                          </a:solidFill>
+                          <a:latin typeface="Arial" pitchFamily="34" charset="0"/>
+                          <a:ea typeface="Arial" pitchFamily="34" charset="-122"/>
+                          <a:cs typeface="Arial" pitchFamily="34" charset="-120"/>
+                        </a:rPr>
+                        <a:t>Serves the Flutter web app; photos and audio</a:t>
+                      </a:r>
+                      <a:endParaRPr lang="en-US" sz="900" dirty="0">
+                        <a:latin typeface="Arial" charset="0"/>
+                        <a:ea typeface="Arial" charset="0"/>
+                        <a:cs typeface="Arial" charset="0"/>
+                      </a:endParaRPr>
+                    </a:p>
+                  </a:txBody>
+                  <a:tcPr marL="45720" marR="45720" marT="45720" marB="45720" anchor="ctr">
+                    <a:lnL w="6350" cap="flat" cmpd="sng" algn="ctr">
+                      <a:solidFill>
+                        <a:srgbClr val="E3DDD4"/>
+                      </a:solidFill>
+                      <a:prstDash val="solid"/>
+                      <a:round/>
+                      <a:headEnd type="none" w="med" len="med"/>
+                      <a:tailEnd type="none" w="med" len="med"/>
+                    </a:lnL>
+                    <a:lnR w="6350" cap="flat" cmpd="sng" algn="ctr">
+                      <a:solidFill>
+                        <a:srgbClr val="E3DDD4"/>
+                      </a:solidFill>
+                      <a:prstDash val="solid"/>
+                      <a:round/>
+                      <a:headEnd type="none" w="med" len="med"/>
+                      <a:tailEnd type="none" w="med" len="med"/>
+                    </a:lnR>
+                    <a:lnT w="6350" cap="flat" cmpd="sng" algn="ctr">
+                      <a:solidFill>
+                        <a:srgbClr val="E3DDD4"/>
+                      </a:solidFill>
+                      <a:prstDash val="solid"/>
+                      <a:round/>
+                      <a:headEnd type="none" w="med" len="med"/>
+                      <a:tailEnd type="none" w="med" len="med"/>
+                    </a:lnT>
+                    <a:lnB w="6350" cap="flat" cmpd="sng" algn="ctr">
+                      <a:solidFill>
+                        <a:srgbClr val="E3DDD4"/>
+                      </a:solidFill>
+                      <a:prstDash val="solid"/>
+                      <a:round/>
+                      <a:headEnd type="none" w="med" len="med"/>
+                      <a:tailEnd type="none" w="med" len="med"/>
+                    </a:lnB>
+                    <a:solidFill>
+                      <a:srgbClr val="FFFFFF"/>
                     </a:solidFill>
                   </a:tcPr>
                 </a:tc>
@@ -16578,7 +16784,7 @@
                       <a:tailEnd type="none" w="med" len="med"/>
                     </a:lnB>
                     <a:solidFill>
-                      <a:srgbClr val="FFFFFF"/>
+                      <a:srgbClr val="FAF7F3"/>
                     </a:solidFill>
                   </a:tcPr>
                 </a:tc>
@@ -16646,7 +16852,7 @@
                       <a:tailEnd type="none" w="med" len="med"/>
                     </a:lnB>
                     <a:solidFill>
-                      <a:srgbClr val="FFFFFF"/>
+                      <a:srgbClr val="FAF7F3"/>
                     </a:solidFill>
                   </a:tcPr>
                 </a:tc>
@@ -16714,7 +16920,7 @@
                       <a:tailEnd type="none" w="med" len="med"/>
                     </a:lnB>
                     <a:solidFill>
-                      <a:srgbClr val="FFFFFF"/>
+                      <a:srgbClr val="FAF7F3"/>
                     </a:solidFill>
                   </a:tcPr>
                 </a:tc>
@@ -16784,7 +16990,7 @@
                       <a:tailEnd type="none" w="med" len="med"/>
                     </a:lnB>
                     <a:solidFill>
-                      <a:srgbClr val="FAF7F3"/>
+                      <a:srgbClr val="FFFFFF"/>
                     </a:solidFill>
                   </a:tcPr>
                 </a:tc>
@@ -16805,7 +17011,7 @@
                           <a:ea typeface="Arial" pitchFamily="34" charset="-122"/>
                           <a:cs typeface="Arial" pitchFamily="34" charset="-120"/>
                         </a:rPr>
-                        <a:t>Cloud SQL · Vertex AI Search · ADK · on-device model</a:t>
+                        <a:t>Firebase Auth · Vertex AI Search · ADK · on-device model</a:t>
                       </a:r>
                       <a:endParaRPr lang="en-US" sz="900" dirty="0">
                         <a:latin typeface="Arial" charset="0"/>
@@ -16852,7 +17058,7 @@
                       <a:tailEnd type="none" w="med" len="med"/>
                     </a:lnB>
                     <a:solidFill>
-                      <a:srgbClr val="FAF7F3"/>
+                      <a:srgbClr val="FFFFFF"/>
                     </a:solidFill>
                   </a:tcPr>
                 </a:tc>
@@ -16873,7 +17079,7 @@
                           <a:ea typeface="Arial" pitchFamily="34" charset="-122"/>
                           <a:cs typeface="Arial" pitchFamily="34" charset="-120"/>
                         </a:rPr>
-                        <a:t>Persistence, catalogue matching, multi-agent orchestration, offline image recognition</a:t>
+                        <a:t>Sign-in, catalogue matching, multi-agent orchestration, offline image recognition</a:t>
                       </a:r>
                       <a:endParaRPr lang="en-US" sz="900" dirty="0">
                         <a:latin typeface="Arial" charset="0"/>
@@ -16920,7 +17126,7 @@
                       <a:tailEnd type="none" w="med" len="med"/>
                     </a:lnB>
                     <a:solidFill>
-                      <a:srgbClr val="FAF7F3"/>
+                      <a:srgbClr val="FFFFFF"/>
                     </a:solidFill>
                   </a:tcPr>
                 </a:tc>
@@ -18106,7 +18312,7 @@
                           <a:ea typeface="Arial" pitchFamily="34" charset="-122"/>
                           <a:cs typeface="Arial" pitchFamily="34" charset="-120"/>
                         </a:rPr>
-                        <a:t>Cloud SQL (roadmap)</a:t>
+                        <a:t>Firestore</a:t>
                       </a:r>
                       <a:endParaRPr lang="en-US" sz="900" dirty="0">
                         <a:latin typeface="Arial" charset="0"/>
@@ -18174,7 +18380,7 @@
                           <a:ea typeface="Arial" pitchFamily="34" charset="-122"/>
                           <a:cs typeface="Arial" pitchFamily="34" charset="-120"/>
                         </a:rPr>
-                        <a:t>One small instance, only when persistence ships</a:t>
+                        <a:t>Documents per shop; inside the free tier at pilot volume</a:t>
                       </a:r>
                       <a:endParaRPr lang="en-US" sz="900" dirty="0">
                         <a:latin typeface="Arial" charset="0"/>
@@ -18242,7 +18448,7 @@
                           <a:ea typeface="Arial" pitchFamily="34" charset="-122"/>
                           <a:cs typeface="Arial" pitchFamily="34" charset="-120"/>
                         </a:rPr>
-                        <a:t>≈ ₹900–1,500</a:t>
+                        <a:t>≈ ₹0 (free tier)</a:t>
                       </a:r>
                       <a:endParaRPr lang="en-US" sz="900" dirty="0">
                         <a:latin typeface="Arial" charset="0"/>

</xml_diff>

<commit_message>
docs(submission): deck architecture and technologies match the final prototype
Co-Authored-By: Claude Fable 5.1 <noreply@anthropic.com>
</commit_message>
<xml_diff>
--- a/docs/submission/Kirana-Mitra-AI-Builder-Cup-Submission.pptx
+++ b/docs/submission/Kirana-Mitra-AI-Builder-Cup-Submission.pptx
@@ -11290,7 +11290,7 @@
                   <a:srgbClr val="1A1A1A"/>
                 </a:solidFill>
               </a:rPr>
-              <a:t>BigQuery ML</a:t>
+              <a:t>Firestore + BQML</a:t>
             </a:r>
             <a:endParaRPr lang="en-US" sz="1050" dirty="0"/>
           </a:p>
@@ -11326,7 +11326,7 @@
                   <a:srgbClr val="1A1A1A"/>
                 </a:solidFill>
               </a:rPr>
-              <a:t>Sales history; ARIMA_PLUS forecast with Indian holidays</a:t>
+              <a:t>Shop, stock and orders saved; ARIMA_PLUS forecast with Indian holidays</a:t>
             </a:r>
             <a:endParaRPr lang="en-US" sz="850" dirty="0"/>
           </a:p>
@@ -13816,7 +13816,7 @@
                   <a:srgbClr val="1A1A1A"/>
                 </a:solidFill>
               </a:rPr>
-              <a:t>Flutter web app on Firebase Hosting (also Android) · camera · mic</a:t>
+              <a:t>Flutter web app (Cloud Storage; Android APK) · camera · mic</a:t>
             </a:r>
             <a:endParaRPr lang="en-US" sz="850" dirty="0"/>
           </a:p>
@@ -13915,7 +13915,7 @@
                   <a:srgbClr val="FFFFFF"/>
                 </a:solidFill>
               </a:rPr>
-              <a:t>FastAPI + google-genai SDK; one JSON-schema prompt per task; confidence gate → confirm chip; Cloud Scheduler runs the daily restock check</a:t>
+              <a:t>FastAPI + google-genai SDK; one JSON-schema prompt per task; confidence gate → confirm chip; Firestore client; Cloud Scheduler calls the daily restock endpoint</a:t>
             </a:r>
             <a:endParaRPr lang="en-US" sz="850" dirty="0"/>
           </a:p>
@@ -14039,7 +14039,7 @@
                   <a:srgbClr val="1A1A1A"/>
                 </a:solidFill>
               </a:rPr>
-              <a:t>Reads shelf photos, voice notes and Indic text; catalogue passed in context (RAG-lite); structured JSON output; low thinking for 2–3 s replies</a:t>
+              <a:t>Reads shelf photos, voice notes and Indic text; 40-item catalogue in context; structured JSON output; unknown products offered as new items</a:t>
             </a:r>
             <a:endParaRPr lang="en-US" sz="800" dirty="0"/>
           </a:p>
@@ -14150,6 +14150,174 @@
         <p:spPr>
           <a:xfrm>
             <a:off x="5166360" y="1947672"/>
+            <a:ext cx="3474720" cy="228600"/>
+          </a:xfrm>
+          <a:prstGeom prst="rect">
+            <a:avLst/>
+          </a:prstGeom>
+          <a:noFill/>
+          <a:ln/>
+        </p:spPr>
+        <p:txBody>
+          <a:bodyPr wrap="square" lIns="0" tIns="0" rIns="0" bIns="0" rtlCol="0" anchor="t"/>
+          <a:lstStyle/>
+          <a:p>
+            <a:pPr indent="0" marL="0">
+              <a:buNone/>
+            </a:pPr>
+            <a:r>
+              <a:rPr lang="en-US" sz="1000" b="1" dirty="0">
+                <a:solidFill>
+                  <a:srgbClr val="1A1A1A"/>
+                </a:solidFill>
+              </a:rPr>
+              <a:t>Firestore (Native, asia-south1)</a:t>
+            </a:r>
+            <a:endParaRPr lang="en-US" sz="1000" dirty="0"/>
+          </a:p>
+        </p:txBody>
+      </p:sp>
+      <p:sp>
+        <p:nvSpPr>
+          <p:cNvPr id="18" name="anim arch text 1"/>
+          <p:cNvSpPr txBox="1"/>
+          <p:nvPr/>
+        </p:nvSpPr>
+        <p:spPr>
+          <a:xfrm>
+            <a:off x="5166360" y="2167128"/>
+            <a:ext cx="3474720" cy="338328"/>
+          </a:xfrm>
+          <a:prstGeom prst="rect">
+            <a:avLst/>
+          </a:prstGeom>
+          <a:noFill/>
+          <a:ln/>
+        </p:spPr>
+        <p:txBody>
+          <a:bodyPr wrap="square" lIns="0" tIns="0" rIns="0" bIns="0" rtlCol="0" anchor="t"/>
+          <a:lstStyle/>
+          <a:p>
+            <a:pPr indent="0" marL="0">
+              <a:buNone/>
+            </a:pPr>
+            <a:r>
+              <a:rPr lang="en-US" sz="800" dirty="0">
+                <a:solidFill>
+                  <a:srgbClr val="1A1A1A"/>
+                </a:solidFill>
+              </a:rPr>
+              <a:t>Shops seeded with the catalogue, stock, messages, orders, feedback; transactional updates and undo; survives redeploys</a:t>
+            </a:r>
+            <a:endParaRPr lang="en-US" sz="800" dirty="0"/>
+          </a:p>
+        </p:txBody>
+      </p:sp>
+      <p:sp>
+        <p:nvSpPr>
+          <p:cNvPr id="19" name="Shape 17"/>
+          <p:cNvSpPr/>
+          <p:nvPr/>
+        </p:nvSpPr>
+        <p:spPr>
+          <a:xfrm>
+            <a:off x="4526280" y="2514600"/>
+            <a:ext cx="228600" cy="0"/>
+          </a:xfrm>
+          <a:prstGeom prst="line">
+            <a:avLst/>
+          </a:prstGeom>
+          <a:noFill/>
+          <a:ln w="19050">
+            <a:solidFill>
+              <a:srgbClr val="E8742B"/>
+            </a:solidFill>
+            <a:prstDash val="solid"/>
+          </a:ln>
+        </p:spPr>
+      </p:sp>
+      <p:sp>
+        <p:nvSpPr>
+          <p:cNvPr id="20" name="Shape 18"/>
+          <p:cNvSpPr/>
+          <p:nvPr/>
+        </p:nvSpPr>
+        <p:spPr>
+          <a:xfrm>
+            <a:off x="4754880" y="2194560"/>
+            <a:ext cx="0" cy="320040"/>
+          </a:xfrm>
+          <a:prstGeom prst="line">
+            <a:avLst/>
+          </a:prstGeom>
+          <a:noFill/>
+          <a:ln w="19050">
+            <a:solidFill>
+              <a:srgbClr val="E8742B"/>
+            </a:solidFill>
+            <a:prstDash val="solid"/>
+          </a:ln>
+        </p:spPr>
+      </p:sp>
+      <p:sp>
+        <p:nvSpPr>
+          <p:cNvPr id="21" name="Shape 19"/>
+          <p:cNvSpPr/>
+          <p:nvPr/>
+        </p:nvSpPr>
+        <p:spPr>
+          <a:xfrm>
+            <a:off x="4754880" y="2194560"/>
+            <a:ext cx="274320" cy="0"/>
+          </a:xfrm>
+          <a:prstGeom prst="line">
+            <a:avLst/>
+          </a:prstGeom>
+          <a:noFill/>
+          <a:ln w="19050">
+            <a:solidFill>
+              <a:srgbClr val="E8742B"/>
+            </a:solidFill>
+            <a:prstDash val="solid"/>
+          </a:ln>
+        </p:spPr>
+      </p:sp>
+      <p:sp>
+        <p:nvSpPr>
+          <p:cNvPr id="22" name="Shape 20"/>
+          <p:cNvSpPr/>
+          <p:nvPr/>
+        </p:nvSpPr>
+        <p:spPr>
+          <a:xfrm>
+            <a:off x="5029200" y="2596896"/>
+            <a:ext cx="3703320" cy="621792"/>
+          </a:xfrm>
+          <a:prstGeom prst="roundRect">
+            <a:avLst>
+              <a:gd name="adj" fmla="val 11765"/>
+            </a:avLst>
+          </a:prstGeom>
+          <a:solidFill>
+            <a:srgbClr val="F3EFEA"/>
+          </a:solidFill>
+          <a:ln w="12700">
+            <a:solidFill>
+              <a:srgbClr val="F3EFEA"/>
+            </a:solidFill>
+            <a:prstDash val="solid"/>
+          </a:ln>
+        </p:spPr>
+      </p:sp>
+      <p:sp>
+        <p:nvSpPr>
+          <p:cNvPr id="23" name="anim arch head 2"/>
+          <p:cNvSpPr txBox="1"/>
+          <p:nvPr/>
+        </p:nvSpPr>
+        <p:spPr>
+          <a:xfrm>
+            <a:off x="5166360" y="2660904"/>
             <a:ext cx="3474720" cy="228600"/>
           </a:xfrm>
           <a:prstGeom prst="rect">
@@ -14179,13 +14347,13 @@
       </p:sp>
       <p:sp>
         <p:nvSpPr>
-          <p:cNvPr id="18" name="anim arch text 1"/>
+          <p:cNvPr id="24" name="anim arch text 2"/>
           <p:cNvSpPr txBox="1"/>
           <p:nvPr/>
         </p:nvSpPr>
         <p:spPr>
           <a:xfrm>
-            <a:off x="5166360" y="2167128"/>
+            <a:off x="5166360" y="2880360"/>
             <a:ext cx="3474720" cy="338328"/>
           </a:xfrm>
           <a:prstGeom prst="rect">
@@ -14207,7 +14375,7 @@
                   <a:srgbClr val="1A1A1A"/>
                 </a:solidFill>
               </a:rPr>
-              <a:t>Sales history, ARIMA_PLUS forecast with HOLIDAY_REGION = IN, feedback table</a:t>
+              <a:t>Sales history; ARIMA_PLUS forecast with HOLIDAY_REGION = IN and festival uplift; feedback table</a:t>
             </a:r>
             <a:endParaRPr lang="en-US" sz="800" dirty="0"/>
           </a:p>
@@ -14215,7 +14383,7 @@
       </p:sp>
       <p:sp>
         <p:nvSpPr>
-          <p:cNvPr id="19" name="Shape 17"/>
+          <p:cNvPr id="25" name="Shape 23"/>
           <p:cNvSpPr/>
           <p:nvPr/>
         </p:nvSpPr>
@@ -14238,14 +14406,14 @@
       </p:sp>
       <p:sp>
         <p:nvSpPr>
-          <p:cNvPr id="20" name="Shape 18"/>
+          <p:cNvPr id="26" name="Shape 24"/>
           <p:cNvSpPr/>
           <p:nvPr/>
         </p:nvSpPr>
         <p:spPr>
           <a:xfrm>
-            <a:off x="4754880" y="2194560"/>
-            <a:ext cx="0" cy="320040"/>
+            <a:off x="4754880" y="2514600"/>
+            <a:ext cx="0" cy="393192"/>
           </a:xfrm>
           <a:prstGeom prst="line">
             <a:avLst/>
@@ -14261,13 +14429,13 @@
       </p:sp>
       <p:sp>
         <p:nvSpPr>
-          <p:cNvPr id="21" name="Shape 19"/>
+          <p:cNvPr id="27" name="Shape 25"/>
           <p:cNvSpPr/>
           <p:nvPr/>
         </p:nvSpPr>
         <p:spPr>
           <a:xfrm>
-            <a:off x="4754880" y="2194560"/>
+            <a:off x="4754880" y="2907792"/>
             <a:ext cx="274320" cy="0"/>
           </a:xfrm>
           <a:prstGeom prst="line">
@@ -14284,13 +14452,13 @@
       </p:sp>
       <p:sp>
         <p:nvSpPr>
-          <p:cNvPr id="22" name="Shape 20"/>
+          <p:cNvPr id="28" name="Shape 26"/>
           <p:cNvSpPr/>
           <p:nvPr/>
         </p:nvSpPr>
         <p:spPr>
           <a:xfrm>
-            <a:off x="5029200" y="2596896"/>
+            <a:off x="5029200" y="3310128"/>
             <a:ext cx="3703320" cy="621792"/>
           </a:xfrm>
           <a:prstGeom prst="roundRect">
@@ -14311,13 +14479,13 @@
       </p:sp>
       <p:sp>
         <p:nvSpPr>
-          <p:cNvPr id="23" name="anim arch head 2"/>
+          <p:cNvPr id="29" name="anim arch head 3"/>
           <p:cNvSpPr txBox="1"/>
           <p:nvPr/>
         </p:nvSpPr>
         <p:spPr>
           <a:xfrm>
-            <a:off x="5166360" y="2660904"/>
+            <a:off x="5166360" y="3374136"/>
             <a:ext cx="3474720" cy="228600"/>
           </a:xfrm>
           <a:prstGeom prst="rect">
@@ -14339,7 +14507,7 @@
                   <a:srgbClr val="1A1A1A"/>
                 </a:solidFill>
               </a:rPr>
-              <a:t>Firebase Hosting + Cloud Storage</a:t>
+              <a:t>Cloud Storage · Firebase project</a:t>
             </a:r>
             <a:endParaRPr lang="en-US" sz="1000" dirty="0"/>
           </a:p>
@@ -14347,13 +14515,13 @@
       </p:sp>
       <p:sp>
         <p:nvSpPr>
-          <p:cNvPr id="24" name="anim arch text 2"/>
+          <p:cNvPr id="30" name="anim arch text 3"/>
           <p:cNvSpPr txBox="1"/>
           <p:nvPr/>
         </p:nvSpPr>
         <p:spPr>
           <a:xfrm>
-            <a:off x="5166360" y="2880360"/>
+            <a:off x="5166360" y="3593592"/>
             <a:ext cx="3474720" cy="338328"/>
           </a:xfrm>
           <a:prstGeom prst="rect">
@@ -14375,175 +14543,7 @@
                   <a:srgbClr val="1A1A1A"/>
                 </a:solidFill>
               </a:rPr>
-              <a:t>Serves the Flutter web app; shelf photos and voice audio</a:t>
-            </a:r>
-            <a:endParaRPr lang="en-US" sz="800" dirty="0"/>
-          </a:p>
-        </p:txBody>
-      </p:sp>
-      <p:sp>
-        <p:nvSpPr>
-          <p:cNvPr id="25" name="Shape 23"/>
-          <p:cNvSpPr/>
-          <p:nvPr/>
-        </p:nvSpPr>
-        <p:spPr>
-          <a:xfrm>
-            <a:off x="4526280" y="2514600"/>
-            <a:ext cx="228600" cy="0"/>
-          </a:xfrm>
-          <a:prstGeom prst="line">
-            <a:avLst/>
-          </a:prstGeom>
-          <a:noFill/>
-          <a:ln w="19050">
-            <a:solidFill>
-              <a:srgbClr val="E8742B"/>
-            </a:solidFill>
-            <a:prstDash val="solid"/>
-          </a:ln>
-        </p:spPr>
-      </p:sp>
-      <p:sp>
-        <p:nvSpPr>
-          <p:cNvPr id="26" name="Shape 24"/>
-          <p:cNvSpPr/>
-          <p:nvPr/>
-        </p:nvSpPr>
-        <p:spPr>
-          <a:xfrm>
-            <a:off x="4754880" y="2514600"/>
-            <a:ext cx="0" cy="393192"/>
-          </a:xfrm>
-          <a:prstGeom prst="line">
-            <a:avLst/>
-          </a:prstGeom>
-          <a:noFill/>
-          <a:ln w="19050">
-            <a:solidFill>
-              <a:srgbClr val="E8742B"/>
-            </a:solidFill>
-            <a:prstDash val="solid"/>
-          </a:ln>
-        </p:spPr>
-      </p:sp>
-      <p:sp>
-        <p:nvSpPr>
-          <p:cNvPr id="27" name="Shape 25"/>
-          <p:cNvSpPr/>
-          <p:nvPr/>
-        </p:nvSpPr>
-        <p:spPr>
-          <a:xfrm>
-            <a:off x="4754880" y="2907792"/>
-            <a:ext cx="274320" cy="0"/>
-          </a:xfrm>
-          <a:prstGeom prst="line">
-            <a:avLst/>
-          </a:prstGeom>
-          <a:noFill/>
-          <a:ln w="19050">
-            <a:solidFill>
-              <a:srgbClr val="E8742B"/>
-            </a:solidFill>
-            <a:prstDash val="solid"/>
-          </a:ln>
-        </p:spPr>
-      </p:sp>
-      <p:sp>
-        <p:nvSpPr>
-          <p:cNvPr id="28" name="Shape 26"/>
-          <p:cNvSpPr/>
-          <p:nvPr/>
-        </p:nvSpPr>
-        <p:spPr>
-          <a:xfrm>
-            <a:off x="5029200" y="3310128"/>
-            <a:ext cx="3703320" cy="621792"/>
-          </a:xfrm>
-          <a:prstGeom prst="roundRect">
-            <a:avLst>
-              <a:gd name="adj" fmla="val 11765"/>
-            </a:avLst>
-          </a:prstGeom>
-          <a:solidFill>
-            <a:srgbClr val="F3EFEA"/>
-          </a:solidFill>
-          <a:ln w="12700">
-            <a:solidFill>
-              <a:srgbClr val="F3EFEA"/>
-            </a:solidFill>
-            <a:prstDash val="solid"/>
-          </a:ln>
-        </p:spPr>
-      </p:sp>
-      <p:sp>
-        <p:nvSpPr>
-          <p:cNvPr id="29" name="anim arch head 3"/>
-          <p:cNvSpPr txBox="1"/>
-          <p:nvPr/>
-        </p:nvSpPr>
-        <p:spPr>
-          <a:xfrm>
-            <a:off x="5166360" y="3374136"/>
-            <a:ext cx="3474720" cy="228600"/>
-          </a:xfrm>
-          <a:prstGeom prst="rect">
-            <a:avLst/>
-          </a:prstGeom>
-          <a:noFill/>
-          <a:ln/>
-        </p:spPr>
-        <p:txBody>
-          <a:bodyPr wrap="square" lIns="0" tIns="0" rIns="0" bIns="0" rtlCol="0" anchor="t"/>
-          <a:lstStyle/>
-          <a:p>
-            <a:pPr indent="0" marL="0">
-              <a:buNone/>
-            </a:pPr>
-            <a:r>
-              <a:rPr lang="en-US" sz="1000" b="1" dirty="0">
-                <a:solidFill>
-                  <a:srgbClr val="1A1A1A"/>
-                </a:solidFill>
-              </a:rPr>
-              <a:t>Firestore</a:t>
-            </a:r>
-            <a:endParaRPr lang="en-US" sz="1000" dirty="0"/>
-          </a:p>
-        </p:txBody>
-      </p:sp>
-      <p:sp>
-        <p:nvSpPr>
-          <p:cNvPr id="30" name="anim arch text 3"/>
-          <p:cNvSpPr txBox="1"/>
-          <p:nvPr/>
-        </p:nvSpPr>
-        <p:spPr>
-          <a:xfrm>
-            <a:off x="5166360" y="3593592"/>
-            <a:ext cx="3474720" cy="338328"/>
-          </a:xfrm>
-          <a:prstGeom prst="rect">
-            <a:avLst/>
-          </a:prstGeom>
-          <a:noFill/>
-          <a:ln/>
-        </p:spPr>
-        <p:txBody>
-          <a:bodyPr wrap="square" lIns="0" tIns="0" rIns="0" bIns="0" rtlCol="0" anchor="t"/>
-          <a:lstStyle/>
-          <a:p>
-            <a:pPr indent="0" marL="0">
-              <a:buNone/>
-            </a:pPr>
-            <a:r>
-              <a:rPr lang="en-US" sz="800" dirty="0">
-                <a:solidFill>
-                  <a:srgbClr val="1A1A1A"/>
-                </a:solidFill>
-              </a:rPr>
-              <a:t>Shops, items, stock, messages, orders and feedback as documents; stock updates and undo in transactions</a:t>
+              <a:t>Serves the Flutter web app today; photos and audio; Firebase Hosting configured as the next web target</a:t>
             </a:r>
             <a:endParaRPr lang="en-US" sz="800" dirty="0"/>
           </a:p>
@@ -14675,7 +14675,7 @@
                   <a:srgbClr val="5F5F5F"/>
                 </a:solidFill>
               </a:rPr>
-              <a:t>Vertex AI Search + ADK (roadmap)</a:t>
+              <a:t>Roadmap: Firebase Auth · Vertex AI Search · ADK</a:t>
             </a:r>
             <a:endParaRPr lang="en-US" sz="1000" dirty="0"/>
           </a:p>
@@ -14711,7 +14711,7 @@
                   <a:srgbClr val="5F5F5F"/>
                 </a:solidFill>
               </a:rPr>
-              <a:t>Catalogue matching for spoken names; multi-agent orchestration for godown and distributor flows</a:t>
+              <a:t>Sign-in, catalogue matching for spoken names, multi-agent godown and distributor flows</a:t>
             </a:r>
             <a:endParaRPr lang="en-US" sz="800" dirty="0"/>
           </a:p>
@@ -16255,7 +16255,7 @@
                           <a:ea typeface="Arial" pitchFamily="34" charset="-122"/>
                           <a:cs typeface="Arial" pitchFamily="34" charset="-120"/>
                         </a:rPr>
-                        <a:t>FastAPI API; scales to zero when idle; daily auto-restock check with a token-gated endpoint</a:t>
+                        <a:t>FastAPI API on one warm instance; daily 06:00 auto-restock run through a token-gated endpoint</a:t>
                       </a:r>
                       <a:endParaRPr lang="en-US" sz="900" dirty="0">
                         <a:latin typeface="Arial" charset="0"/>
@@ -16461,7 +16461,7 @@
                           <a:ea typeface="Arial" pitchFamily="34" charset="-122"/>
                           <a:cs typeface="Arial" pitchFamily="34" charset="-120"/>
                         </a:rPr>
-                        <a:t>Shops, items, stock, messages, orders and feedback; transactional stock updates and undo</a:t>
+                        <a:t>Shops seeded with the 40-item catalogue, stock, messages, orders and feedback; transactional updates and undo; data survives redeploys</a:t>
                       </a:r>
                       <a:endParaRPr lang="en-US" sz="900" dirty="0">
                         <a:latin typeface="Arial" charset="0"/>
@@ -16599,7 +16599,7 @@
                           <a:ea typeface="Arial" pitchFamily="34" charset="-122"/>
                           <a:cs typeface="Arial" pitchFamily="34" charset="-120"/>
                         </a:rPr>
-                        <a:t>Firebase Hosting, Cloud Storage</a:t>
+                        <a:t>Cloud Storage · Firebase project</a:t>
                       </a:r>
                       <a:endParaRPr lang="en-US" sz="900" dirty="0">
                         <a:latin typeface="Arial" charset="0"/>
@@ -16667,7 +16667,7 @@
                           <a:ea typeface="Arial" pitchFamily="34" charset="-122"/>
                           <a:cs typeface="Arial" pitchFamily="34" charset="-120"/>
                         </a:rPr>
-                        <a:t>Serves the Flutter web app; photos and audio</a:t>
+                        <a:t>Cloud Storage serves the Flutter web build and holds photos and audio; Firebase Hosting configured for the web app</a:t>
                       </a:r>
                       <a:endParaRPr lang="en-US" sz="900" dirty="0">
                         <a:latin typeface="Arial" charset="0"/>
@@ -16805,7 +16805,7 @@
                           <a:ea typeface="Arial" pitchFamily="34" charset="-122"/>
                           <a:cs typeface="Arial" pitchFamily="34" charset="-120"/>
                         </a:rPr>
-                        <a:t>Flutter (web now, Android APK built)</a:t>
+                        <a:t>Flutter (web live, Android APK built)</a:t>
                       </a:r>
                       <a:endParaRPr lang="en-US" sz="900" dirty="0">
                         <a:latin typeface="Arial" charset="0"/>
@@ -16873,7 +16873,7 @@
                           <a:ea typeface="Arial" pitchFamily="34" charset="-122"/>
                           <a:cs typeface="Arial" pitchFamily="34" charset="-120"/>
                         </a:rPr>
-                        <a:t>Chat-style app: hold-to-talk, camera, 56 dp targets, works on low-end phones</a:t>
+                        <a:t>Chat-style app: hold-to-talk, camera or sample shelf, real product photos, self-healing shop session, 56 dp targets</a:t>
                       </a:r>
                       <a:endParaRPr lang="en-US" sz="900" dirty="0">
                         <a:latin typeface="Arial" charset="0"/>

</xml_diff>

<commit_message>
docs(submission): shelf-scan snapshot and native-app plugin roadmap point
Co-Authored-By: Claude Fable 5.1 <noreply@anthropic.com>
</commit_message>
<xml_diff>
--- a/docs/submission/Kirana-Mitra-AI-Builder-Cup-Submission.pptx
+++ b/docs/submission/Kirana-Mitra-AI-Builder-Cup-Submission.pptx
@@ -2813,8 +2813,8 @@
         </p:blipFill>
         <p:spPr>
           <a:xfrm>
-            <a:off x="685800" y="1188720"/>
-            <a:ext cx="1572768" cy="3291840"/>
+            <a:off x="502920" y="1188720"/>
+            <a:ext cx="1572768" cy="3200400"/>
           </a:xfrm>
           <a:prstGeom prst="rect">
             <a:avLst/>
@@ -2829,8 +2829,8 @@
         </p:nvSpPr>
         <p:spPr>
           <a:xfrm>
-            <a:off x="594360" y="4526280"/>
-            <a:ext cx="2468880" cy="274320"/>
+            <a:off x="320040" y="4434840"/>
+            <a:ext cx="1965960" cy="365760"/>
           </a:xfrm>
           <a:prstGeom prst="rect">
             <a:avLst/>
@@ -2846,20 +2846,20 @@
               <a:buNone/>
             </a:pPr>
             <a:r>
-              <a:rPr lang="en-US" sz="800" dirty="0">
+              <a:rPr lang="en-US" sz="750" dirty="0">
                 <a:solidFill>
                   <a:srgbClr val="5F5F5F"/>
                 </a:solidFill>
               </a:rPr>
-              <a:t>Voice or typed entry → confirmation card with Undo (live, Cloud Run)</a:t>
+              <a:t>Typed or spoken entry → confirmation card with Undo (live)</a:t>
             </a:r>
-            <a:endParaRPr lang="en-US" sz="800" dirty="0"/>
+            <a:endParaRPr lang="en-US" sz="750" dirty="0"/>
           </a:p>
         </p:txBody>
       </p:sp>
       <p:pic>
         <p:nvPicPr>
-          <p:cNvPr id="5" name="anim shot 1" descr="shot_forecast.jpg">    </p:cNvPr>
+          <p:cNvPr id="5" name="anim shot 1" descr="shot_scan.png">    </p:cNvPr>
           <p:cNvPicPr>
             <a:picLocks noChangeAspect="1"/>
           </p:cNvPicPr>
@@ -2872,8 +2872,8 @@
         </p:blipFill>
         <p:spPr>
           <a:xfrm>
-            <a:off x="3429000" y="1188720"/>
-            <a:ext cx="1572768" cy="3291840"/>
+            <a:off x="2606040" y="1188720"/>
+            <a:ext cx="1572768" cy="3200400"/>
           </a:xfrm>
           <a:prstGeom prst="rect">
             <a:avLst/>
@@ -2888,8 +2888,8 @@
         </p:nvSpPr>
         <p:spPr>
           <a:xfrm>
-            <a:off x="3337560" y="4526280"/>
-            <a:ext cx="2468880" cy="274320"/>
+            <a:off x="2423160" y="4434840"/>
+            <a:ext cx="1965960" cy="365760"/>
           </a:xfrm>
           <a:prstGeom prst="rect">
             <a:avLst/>
@@ -2905,20 +2905,20 @@
               <a:buNone/>
             </a:pPr>
             <a:r>
-              <a:rPr lang="en-US" sz="800" dirty="0">
+              <a:rPr lang="en-US" sz="750" dirty="0">
                 <a:solidFill>
                   <a:srgbClr val="5F5F5F"/>
                 </a:solidFill>
               </a:rPr>
-              <a:t>4-week forecast with Dussehra and Diwali markers, reorder in one tap</a:t>
+              <a:t>Shelf photo → counts, low-stock badge, stock updated with Undo</a:t>
             </a:r>
-            <a:endParaRPr lang="en-US" sz="800" dirty="0"/>
+            <a:endParaRPr lang="en-US" sz="750" dirty="0"/>
           </a:p>
         </p:txBody>
       </p:sp>
       <p:pic>
         <p:nvPicPr>
-          <p:cNvPr id="7" name="anim shot 2" descr="shot_phone.png">    </p:cNvPr>
+          <p:cNvPr id="7" name="anim shot 2" descr="shot_forecast.jpg">    </p:cNvPr>
           <p:cNvPicPr>
             <a:picLocks noChangeAspect="1"/>
           </p:cNvPicPr>
@@ -2931,8 +2931,8 @@
         </p:blipFill>
         <p:spPr>
           <a:xfrm>
-            <a:off x="6172200" y="1188720"/>
-            <a:ext cx="1572768" cy="3291840"/>
+            <a:off x="4709160" y="1188720"/>
+            <a:ext cx="1572768" cy="3200400"/>
           </a:xfrm>
           <a:prstGeom prst="rect">
             <a:avLst/>
@@ -2947,8 +2947,8 @@
         </p:nvSpPr>
         <p:spPr>
           <a:xfrm>
-            <a:off x="6080760" y="4526280"/>
-            <a:ext cx="2468880" cy="274320"/>
+            <a:off x="4526280" y="4434840"/>
+            <a:ext cx="1965960" cy="365760"/>
           </a:xfrm>
           <a:prstGeom prst="rect">
             <a:avLst/>
@@ -2964,14 +2964,73 @@
               <a:buNone/>
             </a:pPr>
             <a:r>
-              <a:rPr lang="en-US" sz="800" dirty="0">
+              <a:rPr lang="en-US" sz="750" dirty="0">
+                <a:solidFill>
+                  <a:srgbClr val="5F5F5F"/>
+                </a:solidFill>
+              </a:rPr>
+              <a:t>4-week forecast with festival markers, reorder in one tap</a:t>
+            </a:r>
+            <a:endParaRPr lang="en-US" sz="750" dirty="0"/>
+          </a:p>
+        </p:txBody>
+      </p:sp>
+      <p:pic>
+        <p:nvPicPr>
+          <p:cNvPr id="9" name="anim shot 3" descr="shot_phone.png">    </p:cNvPr>
+          <p:cNvPicPr>
+            <a:picLocks noChangeAspect="1"/>
+          </p:cNvPicPr>
+          <p:nvPr/>
+        </p:nvPicPr>
+        <p:blipFill>
+          <a:blip r:embed="rId4"/>
+          <a:srcRect l="0" r="0" t="0" b="0"/>
+          <a:stretch/>
+        </p:blipFill>
+        <p:spPr>
+          <a:xfrm>
+            <a:off x="6812280" y="1188720"/>
+            <a:ext cx="1572768" cy="3200400"/>
+          </a:xfrm>
+          <a:prstGeom prst="rect">
+            <a:avLst/>
+          </a:prstGeom>
+        </p:spPr>
+      </p:pic>
+      <p:sp>
+        <p:nvSpPr>
+          <p:cNvPr id="10" name="Text 4"/>
+          <p:cNvSpPr txBox="1"/>
+          <p:nvPr/>
+        </p:nvSpPr>
+        <p:spPr>
+          <a:xfrm>
+            <a:off x="6629400" y="4434840"/>
+            <a:ext cx="1965960" cy="365760"/>
+          </a:xfrm>
+          <a:prstGeom prst="rect">
+            <a:avLst/>
+          </a:prstGeom>
+          <a:noFill/>
+          <a:ln/>
+        </p:spPr>
+        <p:txBody>
+          <a:bodyPr wrap="square" lIns="0" tIns="0" rIns="0" bIns="0" rtlCol="0" anchor="t"/>
+          <a:lstStyle/>
+          <a:p>
+            <a:pPr indent="0" marL="0">
+              <a:buNone/>
+            </a:pPr>
+            <a:r>
+              <a:rPr lang="en-US" sz="750" dirty="0">
                 <a:solidFill>
                   <a:srgbClr val="5F5F5F"/>
                 </a:solidFill>
               </a:rPr>
               <a:t>The same app on a ₹10k Android phone (OnePlus, Android 11)</a:t>
             </a:r>
-            <a:endParaRPr lang="en-US" sz="800" dirty="0"/>
+            <a:endParaRPr lang="en-US" sz="750" dirty="0"/>
           </a:p>
         </p:txBody>
       </p:sp>
@@ -2992,13 +3051,13 @@
               <p:cTn id="2" dur="indefinite" nodeType="mainSeq">
                 <p:childTnLst>
                   <p:par>
-                    <p:cTn id="12" fill="hold">
+                    <p:cTn id="15" fill="hold">
                       <p:stCondLst>
                         <p:cond delay="indefinite"/>
                       </p:stCondLst>
                       <p:childTnLst>
                         <p:par>
-                          <p:cTn id="13" fill="hold">
+                          <p:cTn id="16" fill="hold">
                             <p:stCondLst>
                               <p:cond delay="0"/>
                             </p:stCondLst>
@@ -3102,6 +3161,41 @@
                                         <p:cTn id="11" dur="400"/>
                                         <p:tgtEl>
                                           <p:spTgt spid="7"/>
+                                        </p:tgtEl>
+                                      </p:cBhvr>
+                                    </p:animEffect>
+                                  </p:childTnLst>
+                                </p:cTn>
+                              </p:par>
+                              <p:par>
+                                <p:cTn id="12" presetID="10" presetClass="entr" presetSubtype="0" fill="hold" grpId="0" nodeType="withEffect">
+                                  <p:stCondLst>
+                                    <p:cond delay="750"/>
+                                  </p:stCondLst>
+                                  <p:childTnLst>
+                                    <p:set>
+                                      <p:cBhvr>
+                                        <p:cTn id="13" dur="1" fill="hold">
+                                          <p:stCondLst>
+                                            <p:cond delay="0"/>
+                                          </p:stCondLst>
+                                        </p:cTn>
+                                        <p:tgtEl>
+                                          <p:spTgt spid="9"/>
+                                        </p:tgtEl>
+                                        <p:attrNameLst>
+                                          <p:attrName>style.visibility</p:attrName>
+                                        </p:attrNameLst>
+                                      </p:cBhvr>
+                                      <p:to>
+                                        <p:strVal val="visible"/>
+                                      </p:to>
+                                    </p:set>
+                                    <p:animEffect transition="in" filter="fade">
+                                      <p:cBhvr>
+                                        <p:cTn id="14" dur="400"/>
+                                        <p:tgtEl>
+                                          <p:spTgt spid="9"/>
                                         </p:tgtEl>
                                       </p:cBhvr>
                                     </p:animEffect>
@@ -4572,7 +4666,7 @@
         <p:spPr>
           <a:xfrm>
             <a:off x="411480" y="1188720"/>
-            <a:ext cx="2697480" cy="1463040"/>
+            <a:ext cx="1965960" cy="1463040"/>
           </a:xfrm>
           <a:prstGeom prst="roundRect">
             <a:avLst>
@@ -4623,7 +4717,7 @@
         <p:spPr>
           <a:xfrm>
             <a:off x="576072" y="1645920"/>
-            <a:ext cx="2368296" cy="274320"/>
+            <a:ext cx="1636776" cy="274320"/>
           </a:xfrm>
           <a:prstGeom prst="rect">
             <a:avLst/>
@@ -4639,14 +4733,14 @@
               <a:buNone/>
             </a:pPr>
             <a:r>
-              <a:rPr lang="en-US" sz="1200" b="1" dirty="0">
+              <a:rPr lang="en-US" sz="1050" b="1" dirty="0">
                 <a:solidFill>
                   <a:srgbClr val="1A1A1A"/>
                 </a:solidFill>
               </a:rPr>
               <a:t>Godown plugin</a:t>
             </a:r>
-            <a:endParaRPr lang="en-US" sz="1200" dirty="0"/>
+            <a:endParaRPr lang="en-US" sz="1050" dirty="0"/>
           </a:p>
         </p:txBody>
       </p:sp>
@@ -4659,7 +4753,7 @@
         <p:spPr>
           <a:xfrm>
             <a:off x="576072" y="1938528"/>
-            <a:ext cx="2368296" cy="594360"/>
+            <a:ext cx="1636776" cy="594360"/>
           </a:xfrm>
           <a:prstGeom prst="rect">
             <a:avLst/>
@@ -4675,14 +4769,14 @@
               <a:buNone/>
             </a:pPr>
             <a:r>
-              <a:rPr lang="en-US" sz="1000" dirty="0">
+              <a:rPr lang="en-US" sz="850" dirty="0">
                 <a:solidFill>
                   <a:srgbClr val="1A1A1A"/>
                 </a:solidFill>
               </a:rPr>
               <a:t>Warehouse stock alongside the shelf: shelf check → godown double-check → then prompt the kirana to place the order with the distributor.</a:t>
             </a:r>
-            <a:endParaRPr lang="en-US" sz="1000" dirty="0"/>
+            <a:endParaRPr lang="en-US" sz="850" dirty="0"/>
           </a:p>
         </p:txBody>
       </p:sp>
@@ -4694,8 +4788,8 @@
         </p:nvSpPr>
         <p:spPr>
           <a:xfrm>
-            <a:off x="3246120" y="1188720"/>
-            <a:ext cx="2697480" cy="1463040"/>
+            <a:off x="2514600" y="1188720"/>
+            <a:ext cx="1965960" cy="1463040"/>
           </a:xfrm>
           <a:prstGeom prst="roundRect">
             <a:avLst>
@@ -4729,7 +4823,7 @@
         </p:blipFill>
         <p:spPr>
           <a:xfrm>
-            <a:off x="3410712" y="1344168"/>
+            <a:off x="2679192" y="1344168"/>
             <a:ext cx="237744" cy="237744"/>
           </a:xfrm>
           <a:prstGeom prst="rect">
@@ -4745,8 +4839,8 @@
         </p:nvSpPr>
         <p:spPr>
           <a:xfrm>
-            <a:off x="3410712" y="1645920"/>
-            <a:ext cx="2368296" cy="274320"/>
+            <a:off x="2679192" y="1645920"/>
+            <a:ext cx="1636776" cy="274320"/>
           </a:xfrm>
           <a:prstGeom prst="rect">
             <a:avLst/>
@@ -4762,14 +4856,14 @@
               <a:buNone/>
             </a:pPr>
             <a:r>
-              <a:rPr lang="en-US" sz="1200" b="1" dirty="0">
+              <a:rPr lang="en-US" sz="1050" b="1" dirty="0">
                 <a:solidFill>
                   <a:srgbClr val="1A1A1A"/>
                 </a:solidFill>
               </a:rPr>
               <a:t>Offline image model</a:t>
             </a:r>
-            <a:endParaRPr lang="en-US" sz="1200" dirty="0"/>
+            <a:endParaRPr lang="en-US" sz="1050" dirty="0"/>
           </a:p>
         </p:txBody>
       </p:sp>
@@ -4781,8 +4875,8 @@
         </p:nvSpPr>
         <p:spPr>
           <a:xfrm>
-            <a:off x="3410712" y="1938528"/>
-            <a:ext cx="2368296" cy="594360"/>
+            <a:off x="2679192" y="1938528"/>
+            <a:ext cx="1636776" cy="594360"/>
           </a:xfrm>
           <a:prstGeom prst="rect">
             <a:avLst/>
@@ -4798,14 +4892,14 @@
               <a:buNone/>
             </a:pPr>
             <a:r>
-              <a:rPr lang="en-US" sz="1000" dirty="0">
+              <a:rPr lang="en-US" sz="850" dirty="0">
                 <a:solidFill>
                   <a:srgbClr val="1A1A1A"/>
                 </a:solidFill>
               </a:rPr>
               <a:t>On-device shelf recognition (Gemini Nano or a TFLite model) so counts work without network and Gemini cost drops for the most frequent call.</a:t>
             </a:r>
-            <a:endParaRPr lang="en-US" sz="1000" dirty="0"/>
+            <a:endParaRPr lang="en-US" sz="850" dirty="0"/>
           </a:p>
         </p:txBody>
       </p:sp>
@@ -4817,8 +4911,8 @@
         </p:nvSpPr>
         <p:spPr>
           <a:xfrm>
-            <a:off x="6080760" y="1188720"/>
-            <a:ext cx="2697480" cy="1463040"/>
+            <a:off x="4617720" y="1188720"/>
+            <a:ext cx="1965960" cy="1463040"/>
           </a:xfrm>
           <a:prstGeom prst="roundRect">
             <a:avLst>
@@ -4852,7 +4946,7 @@
         </p:blipFill>
         <p:spPr>
           <a:xfrm>
-            <a:off x="6245352" y="1344168"/>
+            <a:off x="4782312" y="1344168"/>
             <a:ext cx="237744" cy="237744"/>
           </a:xfrm>
           <a:prstGeom prst="rect">
@@ -4868,8 +4962,8 @@
         </p:nvSpPr>
         <p:spPr>
           <a:xfrm>
-            <a:off x="6245352" y="1645920"/>
-            <a:ext cx="2368296" cy="274320"/>
+            <a:off x="4782312" y="1645920"/>
+            <a:ext cx="1636776" cy="274320"/>
           </a:xfrm>
           <a:prstGeom prst="rect">
             <a:avLst/>
@@ -4885,14 +4979,14 @@
               <a:buNone/>
             </a:pPr>
             <a:r>
-              <a:rPr lang="en-US" sz="1200" b="1" dirty="0">
+              <a:rPr lang="en-US" sz="1050" b="1" dirty="0">
                 <a:solidFill>
                   <a:srgbClr val="1A1A1A"/>
                 </a:solidFill>
               </a:rPr>
               <a:t>Production gaps to close</a:t>
             </a:r>
-            <a:endParaRPr lang="en-US" sz="1200" dirty="0"/>
+            <a:endParaRPr lang="en-US" sz="1050" dirty="0"/>
           </a:p>
         </p:txBody>
       </p:sp>
@@ -4904,8 +4998,8 @@
         </p:nvSpPr>
         <p:spPr>
           <a:xfrm>
-            <a:off x="6245352" y="1938528"/>
-            <a:ext cx="2368296" cy="594360"/>
+            <a:off x="4782312" y="1938528"/>
+            <a:ext cx="1636776" cy="594360"/>
           </a:xfrm>
           <a:prstGeom prst="rect">
             <a:avLst/>
@@ -4921,14 +5015,14 @@
               <a:buNone/>
             </a:pPr>
             <a:r>
-              <a:rPr lang="en-US" sz="1000" dirty="0">
+              <a:rPr lang="en-US" sz="850" dirty="0">
                 <a:solidFill>
                   <a:srgbClr val="1A1A1A"/>
                 </a:solidFill>
               </a:rPr>
               <a:t>Sign-in and per-shop access (Firebase Auth) · real pilot sales and shelves · monitoring, rate limits and Gemini cost caps · backups and Firestore security rules · native review of the 22 languages.</a:t>
             </a:r>
-            <a:endParaRPr lang="en-US" sz="1000" dirty="0"/>
+            <a:endParaRPr lang="en-US" sz="850" dirty="0"/>
           </a:p>
         </p:txBody>
       </p:sp>
@@ -4940,8 +5034,131 @@
         </p:nvSpPr>
         <p:spPr>
           <a:xfrm>
+            <a:off x="6720840" y="1188720"/>
+            <a:ext cx="1965960" cy="1463040"/>
+          </a:xfrm>
+          <a:prstGeom prst="roundRect">
+            <a:avLst>
+              <a:gd name="adj" fmla="val 5000"/>
+            </a:avLst>
+          </a:prstGeom>
+          <a:solidFill>
+            <a:srgbClr val="FBF2E6"/>
+          </a:solidFill>
+          <a:ln w="12700">
+            <a:solidFill>
+              <a:srgbClr val="FBF2E6"/>
+            </a:solidFill>
+            <a:prstDash val="solid"/>
+          </a:ln>
+        </p:spPr>
+      </p:sp>
+      <p:pic>
+        <p:nvPicPr>
+          <p:cNvPr id="16" name="anim 22 languages in the app icon" descr="preencoded.png">    </p:cNvPr>
+          <p:cNvPicPr>
+            <a:picLocks noChangeAspect="1"/>
+          </p:cNvPicPr>
+          <p:nvPr/>
+        </p:nvPicPr>
+        <p:blipFill>
+          <a:blip r:embed="rId4"/>
+          <a:stretch>
+            <a:fillRect/>
+          </a:stretch>
+        </p:blipFill>
+        <p:spPr>
+          <a:xfrm>
+            <a:off x="6885432" y="1344168"/>
+            <a:ext cx="237744" cy="237744"/>
+          </a:xfrm>
+          <a:prstGeom prst="rect">
+            <a:avLst/>
+          </a:prstGeom>
+        </p:spPr>
+      </p:pic>
+      <p:sp>
+        <p:nvSpPr>
+          <p:cNvPr id="17" name="anim 22 languages in the app"/>
+          <p:cNvSpPr txBox="1"/>
+          <p:nvPr/>
+        </p:nvSpPr>
+        <p:spPr>
+          <a:xfrm>
+            <a:off x="6885432" y="1645920"/>
+            <a:ext cx="1636776" cy="274320"/>
+          </a:xfrm>
+          <a:prstGeom prst="rect">
+            <a:avLst/>
+          </a:prstGeom>
+          <a:noFill/>
+          <a:ln/>
+        </p:spPr>
+        <p:txBody>
+          <a:bodyPr wrap="square" lIns="0" tIns="0" rIns="0" bIns="0" rtlCol="0" anchor="t"/>
+          <a:lstStyle/>
+          <a:p>
+            <a:pPr indent="0" marL="0">
+              <a:buNone/>
+            </a:pPr>
+            <a:r>
+              <a:rPr lang="en-US" sz="1050" b="1" dirty="0">
+                <a:solidFill>
+                  <a:srgbClr val="1A1A1A"/>
+                </a:solidFill>
+              </a:rPr>
+              <a:t>22 languages in the app</a:t>
+            </a:r>
+            <a:endParaRPr lang="en-US" sz="1050" dirty="0"/>
+          </a:p>
+        </p:txBody>
+      </p:sp>
+      <p:sp>
+        <p:nvSpPr>
+          <p:cNvPr id="18" name="anim 22 languages in the app text"/>
+          <p:cNvSpPr txBox="1"/>
+          <p:nvPr/>
+        </p:nvSpPr>
+        <p:spPr>
+          <a:xfrm>
+            <a:off x="6885432" y="1938528"/>
+            <a:ext cx="1636776" cy="594360"/>
+          </a:xfrm>
+          <a:prstGeom prst="rect">
+            <a:avLst/>
+          </a:prstGeom>
+          <a:noFill/>
+          <a:ln/>
+        </p:spPr>
+        <p:txBody>
+          <a:bodyPr wrap="square" lIns="0" tIns="0" rIns="0" bIns="0" rtlCol="0" anchor="t"/>
+          <a:lstStyle/>
+          <a:p>
+            <a:pPr indent="0" marL="0">
+              <a:buNone/>
+            </a:pPr>
+            <a:r>
+              <a:rPr lang="en-US" sz="850" dirty="0">
+                <a:solidFill>
+                  <a:srgbClr val="1A1A1A"/>
+                </a:solidFill>
+              </a:rPr>
+              <a:t>Backend already replies in all 22; the generated UI strings ship language by language after native-speaker review, largest eight first.</a:t>
+            </a:r>
+            <a:endParaRPr lang="en-US" sz="850" dirty="0"/>
+          </a:p>
+        </p:txBody>
+      </p:sp>
+      <p:sp>
+        <p:nvSpPr>
+          <p:cNvPr id="19" name="Shape 13"/>
+          <p:cNvSpPr/>
+          <p:nvPr/>
+        </p:nvSpPr>
+        <p:spPr>
+          <a:xfrm>
             <a:off x="411480" y="2761488"/>
-            <a:ext cx="2697480" cy="1463040"/>
+            <a:ext cx="1965960" cy="1463040"/>
           </a:xfrm>
           <a:prstGeom prst="roundRect">
             <a:avLst>
@@ -4961,14 +5178,14 @@
       </p:sp>
       <p:pic>
         <p:nvPicPr>
-          <p:cNvPr id="16" name="anim 22 languages in the app icon" descr="preencoded.png">    </p:cNvPr>
+          <p:cNvPr id="20" name="anim Udhaar ledger &amp; credit icon" descr="preencoded.png">    </p:cNvPr>
           <p:cNvPicPr>
             <a:picLocks noChangeAspect="1"/>
           </p:cNvPicPr>
           <p:nvPr/>
         </p:nvPicPr>
         <p:blipFill>
-          <a:blip r:embed="rId4"/>
+          <a:blip r:embed="rId5"/>
           <a:stretch>
             <a:fillRect/>
           </a:stretch>
@@ -4985,14 +5202,14 @@
       </p:pic>
       <p:sp>
         <p:nvSpPr>
-          <p:cNvPr id="17" name="anim 22 languages in the app"/>
+          <p:cNvPr id="21" name="anim Udhaar ledger &amp;amp; credit"/>
           <p:cNvSpPr txBox="1"/>
           <p:nvPr/>
         </p:nvSpPr>
         <p:spPr>
           <a:xfrm>
             <a:off x="576072" y="3218688"/>
-            <a:ext cx="2368296" cy="274320"/>
+            <a:ext cx="1636776" cy="274320"/>
           </a:xfrm>
           <a:prstGeom prst="rect">
             <a:avLst/>
@@ -5008,27 +5225,27 @@
               <a:buNone/>
             </a:pPr>
             <a:r>
-              <a:rPr lang="en-US" sz="1200" b="1" dirty="0">
+              <a:rPr lang="en-US" sz="1050" b="1" dirty="0">
                 <a:solidFill>
                   <a:srgbClr val="1A1A1A"/>
                 </a:solidFill>
               </a:rPr>
-              <a:t>22 languages in the app</a:t>
+              <a:t>Udhaar ledger &amp; credit</a:t>
             </a:r>
-            <a:endParaRPr lang="en-US" sz="1200" dirty="0"/>
+            <a:endParaRPr lang="en-US" sz="1050" dirty="0"/>
           </a:p>
         </p:txBody>
       </p:sp>
       <p:sp>
         <p:nvSpPr>
-          <p:cNvPr id="18" name="anim 22 languages in the app text"/>
+          <p:cNvPr id="22" name="anim Udhaar ledger &amp;amp; credit text"/>
           <p:cNvSpPr txBox="1"/>
           <p:nvPr/>
         </p:nvSpPr>
         <p:spPr>
           <a:xfrm>
             <a:off x="576072" y="3511296"/>
-            <a:ext cx="2368296" cy="594360"/>
+            <a:ext cx="1636776" cy="594360"/>
           </a:xfrm>
           <a:prstGeom prst="rect">
             <a:avLst/>
@@ -5044,27 +5261,27 @@
               <a:buNone/>
             </a:pPr>
             <a:r>
-              <a:rPr lang="en-US" sz="1000" dirty="0">
+              <a:rPr lang="en-US" sz="850" dirty="0">
                 <a:solidFill>
                   <a:srgbClr val="1A1A1A"/>
                 </a:solidFill>
               </a:rPr>
-              <a:t>Backend already replies in all 22; the generated UI strings ship language by language after native-speaker review, largest eight first.</a:t>
+              <a:t>Voice-logged credit and reminders; clean sales history can help shops qualify for working-capital loans.</a:t>
             </a:r>
-            <a:endParaRPr lang="en-US" sz="1000" dirty="0"/>
+            <a:endParaRPr lang="en-US" sz="850" dirty="0"/>
           </a:p>
         </p:txBody>
       </p:sp>
       <p:sp>
         <p:nvSpPr>
-          <p:cNvPr id="19" name="Shape 13"/>
+          <p:cNvPr id="23" name="Shape 16"/>
           <p:cNvSpPr/>
           <p:nvPr/>
         </p:nvSpPr>
         <p:spPr>
           <a:xfrm>
-            <a:off x="3246120" y="2761488"/>
-            <a:ext cx="2697480" cy="1463040"/>
+            <a:off x="2514600" y="2761488"/>
+            <a:ext cx="1965960" cy="1463040"/>
           </a:xfrm>
           <a:prstGeom prst="roundRect">
             <a:avLst>
@@ -5084,21 +5301,21 @@
       </p:sp>
       <p:pic>
         <p:nvPicPr>
-          <p:cNvPr id="20" name="anim Udhaar ledger &amp; credit icon" descr="preencoded.png">    </p:cNvPr>
+          <p:cNvPr id="24" name="anim Supply forecast &amp; WhatsApp icon" descr="preencoded.png">    </p:cNvPr>
           <p:cNvPicPr>
             <a:picLocks noChangeAspect="1"/>
           </p:cNvPicPr>
           <p:nvPr/>
         </p:nvPicPr>
         <p:blipFill>
-          <a:blip r:embed="rId5"/>
+          <a:blip r:embed="rId6"/>
           <a:stretch>
             <a:fillRect/>
           </a:stretch>
         </p:blipFill>
         <p:spPr>
           <a:xfrm>
-            <a:off x="3410712" y="2916936"/>
+            <a:off x="2679192" y="2916936"/>
             <a:ext cx="237744" cy="237744"/>
           </a:xfrm>
           <a:prstGeom prst="rect">
@@ -5108,14 +5325,14 @@
       </p:pic>
       <p:sp>
         <p:nvSpPr>
-          <p:cNvPr id="21" name="anim Udhaar ledger &amp;amp; credit"/>
+          <p:cNvPr id="25" name="anim Supply forecast &amp;amp; WhatsApp"/>
           <p:cNvSpPr txBox="1"/>
           <p:nvPr/>
         </p:nvSpPr>
         <p:spPr>
           <a:xfrm>
-            <a:off x="3410712" y="3218688"/>
-            <a:ext cx="2368296" cy="274320"/>
+            <a:off x="2679192" y="3218688"/>
+            <a:ext cx="1636776" cy="274320"/>
           </a:xfrm>
           <a:prstGeom prst="rect">
             <a:avLst/>
@@ -5131,27 +5348,27 @@
               <a:buNone/>
             </a:pPr>
             <a:r>
-              <a:rPr lang="en-US" sz="1200" b="1" dirty="0">
+              <a:rPr lang="en-US" sz="1050" b="1" dirty="0">
                 <a:solidFill>
                   <a:srgbClr val="1A1A1A"/>
                 </a:solidFill>
               </a:rPr>
-              <a:t>Udhaar ledger &amp; credit</a:t>
+              <a:t>Supply forecast &amp; WhatsApp</a:t>
             </a:r>
-            <a:endParaRPr lang="en-US" sz="1200" dirty="0"/>
+            <a:endParaRPr lang="en-US" sz="1050" dirty="0"/>
           </a:p>
         </p:txBody>
       </p:sp>
       <p:sp>
         <p:nvSpPr>
-          <p:cNvPr id="22" name="anim Udhaar ledger &amp;amp; credit text"/>
+          <p:cNvPr id="26" name="anim Supply forecast &amp;amp; WhatsApp text"/>
           <p:cNvSpPr txBox="1"/>
           <p:nvPr/>
         </p:nvSpPr>
         <p:spPr>
           <a:xfrm>
-            <a:off x="3410712" y="3511296"/>
-            <a:ext cx="2368296" cy="594360"/>
+            <a:off x="2679192" y="3511296"/>
+            <a:ext cx="1636776" cy="594360"/>
           </a:xfrm>
           <a:prstGeom prst="rect">
             <a:avLst/>
@@ -5167,27 +5384,27 @@
               <a:buNone/>
             </a:pPr>
             <a:r>
-              <a:rPr lang="en-US" sz="1000" dirty="0">
+              <a:rPr lang="en-US" sz="850" dirty="0">
                 <a:solidFill>
                   <a:srgbClr val="1A1A1A"/>
                 </a:solidFill>
               </a:rPr>
-              <a:t>Voice-logged credit and reminders; clean sales history can help shops qualify for working-capital loans.</a:t>
+              <a:t>Distributor lead times and stock-outs in the forecast; WhatsApp-first entry so shopkeepers never install anything.</a:t>
             </a:r>
-            <a:endParaRPr lang="en-US" sz="1000" dirty="0"/>
+            <a:endParaRPr lang="en-US" sz="850" dirty="0"/>
           </a:p>
         </p:txBody>
       </p:sp>
       <p:sp>
         <p:nvSpPr>
-          <p:cNvPr id="23" name="Shape 16"/>
+          <p:cNvPr id="27" name="Shape 19"/>
           <p:cNvSpPr/>
           <p:nvPr/>
         </p:nvSpPr>
         <p:spPr>
           <a:xfrm>
-            <a:off x="6080760" y="2761488"/>
-            <a:ext cx="2697480" cy="1463040"/>
+            <a:off x="4617720" y="2761488"/>
+            <a:ext cx="1965960" cy="1463040"/>
           </a:xfrm>
           <a:prstGeom prst="roundRect">
             <a:avLst>
@@ -5207,21 +5424,21 @@
       </p:sp>
       <p:pic>
         <p:nvPicPr>
-          <p:cNvPr id="24" name="anim Supply forecast &amp; WhatsApp icon" descr="preencoded.png">    </p:cNvPr>
+          <p:cNvPr id="28" name="anim Plugin for native apps icon" descr="preencoded.png">    </p:cNvPr>
           <p:cNvPicPr>
             <a:picLocks noChangeAspect="1"/>
           </p:cNvPicPr>
           <p:nvPr/>
         </p:nvPicPr>
         <p:blipFill>
-          <a:blip r:embed="rId6"/>
+          <a:blip r:embed="rId7"/>
           <a:stretch>
             <a:fillRect/>
           </a:stretch>
         </p:blipFill>
         <p:spPr>
           <a:xfrm>
-            <a:off x="6245352" y="2916936"/>
+            <a:off x="4782312" y="2916936"/>
             <a:ext cx="237744" cy="237744"/>
           </a:xfrm>
           <a:prstGeom prst="rect">
@@ -5231,14 +5448,14 @@
       </p:pic>
       <p:sp>
         <p:nvSpPr>
-          <p:cNvPr id="25" name="anim Supply forecast &amp;amp; WhatsApp"/>
+          <p:cNvPr id="29" name="anim Plugin for native apps"/>
           <p:cNvSpPr txBox="1"/>
           <p:nvPr/>
         </p:nvSpPr>
         <p:spPr>
           <a:xfrm>
-            <a:off x="6245352" y="3218688"/>
-            <a:ext cx="2368296" cy="274320"/>
+            <a:off x="4782312" y="3218688"/>
+            <a:ext cx="1636776" cy="274320"/>
           </a:xfrm>
           <a:prstGeom prst="rect">
             <a:avLst/>
@@ -5254,27 +5471,27 @@
               <a:buNone/>
             </a:pPr>
             <a:r>
-              <a:rPr lang="en-US" sz="1200" b="1" dirty="0">
+              <a:rPr lang="en-US" sz="1050" b="1" dirty="0">
                 <a:solidFill>
                   <a:srgbClr val="1A1A1A"/>
                 </a:solidFill>
               </a:rPr>
-              <a:t>Supply forecast &amp; WhatsApp</a:t>
+              <a:t>Plugin for native apps</a:t>
             </a:r>
-            <a:endParaRPr lang="en-US" sz="1200" dirty="0"/>
+            <a:endParaRPr lang="en-US" sz="1050" dirty="0"/>
           </a:p>
         </p:txBody>
       </p:sp>
       <p:sp>
         <p:nvSpPr>
-          <p:cNvPr id="26" name="anim Supply forecast &amp;amp; WhatsApp text"/>
+          <p:cNvPr id="30" name="anim Plugin for native apps text"/>
           <p:cNvSpPr txBox="1"/>
           <p:nvPr/>
         </p:nvSpPr>
         <p:spPr>
           <a:xfrm>
-            <a:off x="6245352" y="3511296"/>
-            <a:ext cx="2368296" cy="594360"/>
+            <a:off x="4782312" y="3511296"/>
+            <a:ext cx="1636776" cy="594360"/>
           </a:xfrm>
           <a:prstGeom prst="rect">
             <a:avLst/>
@@ -5290,20 +5507,20 @@
               <a:buNone/>
             </a:pPr>
             <a:r>
-              <a:rPr lang="en-US" sz="1000" dirty="0">
+              <a:rPr lang="en-US" sz="850" dirty="0">
                 <a:solidFill>
                   <a:srgbClr val="1A1A1A"/>
                 </a:solidFill>
               </a:rPr>
-              <a:t>Distributor lead times and stock-outs in the forecast; WhatsApp-first entry so shopkeepers never install anything.</a:t>
+              <a:t>An SDK and share-sheet plugin so existing kirana billing, POS and distributor apps on Android can embed voice entry, shelf scan and forecasts.</a:t>
             </a:r>
-            <a:endParaRPr lang="en-US" sz="1000" dirty="0"/>
+            <a:endParaRPr lang="en-US" sz="850" dirty="0"/>
           </a:p>
         </p:txBody>
       </p:sp>
       <p:sp>
         <p:nvSpPr>
-          <p:cNvPr id="27" name="Text 19"/>
+          <p:cNvPr id="31" name="Text 22"/>
           <p:cNvSpPr txBox="1"/>
           <p:nvPr/>
         </p:nvSpPr>
@@ -5354,13 +5571,13 @@
               <p:cTn id="2" dur="indefinite" nodeType="mainSeq">
                 <p:childTnLst>
                   <p:par>
-                    <p:cTn id="57" fill="hold">
+                    <p:cTn id="66" fill="hold">
                       <p:stCondLst>
                         <p:cond delay="indefinite"/>
                       </p:stCondLst>
                       <p:childTnLst>
                         <p:par>
-                          <p:cTn id="58" fill="hold">
+                          <p:cTn id="67" fill="hold">
                             <p:stCondLst>
                               <p:cond delay="0"/>
                             </p:stCondLst>
@@ -5989,6 +6206,111 @@
                                         <p:cTn id="56" dur="400"/>
                                         <p:tgtEl>
                                           <p:spTgt spid="26"/>
+                                        </p:tgtEl>
+                                      </p:cBhvr>
+                                    </p:animEffect>
+                                  </p:childTnLst>
+                                </p:cTn>
+                              </p:par>
+                              <p:par>
+                                <p:cTn id="57" presetID="10" presetClass="entr" presetSubtype="0" fill="hold" grpId="0" nodeType="withEffect">
+                                  <p:stCondLst>
+                                    <p:cond delay="4500"/>
+                                  </p:stCondLst>
+                                  <p:childTnLst>
+                                    <p:set>
+                                      <p:cBhvr>
+                                        <p:cTn id="58" dur="1" fill="hold">
+                                          <p:stCondLst>
+                                            <p:cond delay="0"/>
+                                          </p:stCondLst>
+                                        </p:cTn>
+                                        <p:tgtEl>
+                                          <p:spTgt spid="28"/>
+                                        </p:tgtEl>
+                                        <p:attrNameLst>
+                                          <p:attrName>style.visibility</p:attrName>
+                                        </p:attrNameLst>
+                                      </p:cBhvr>
+                                      <p:to>
+                                        <p:strVal val="visible"/>
+                                      </p:to>
+                                    </p:set>
+                                    <p:animEffect transition="in" filter="fade">
+                                      <p:cBhvr>
+                                        <p:cTn id="59" dur="400"/>
+                                        <p:tgtEl>
+                                          <p:spTgt spid="28"/>
+                                        </p:tgtEl>
+                                      </p:cBhvr>
+                                    </p:animEffect>
+                                  </p:childTnLst>
+                                </p:cTn>
+                              </p:par>
+                              <p:par>
+                                <p:cTn id="60" presetID="10" presetClass="entr" presetSubtype="0" fill="hold" grpId="0" nodeType="withEffect">
+                                  <p:stCondLst>
+                                    <p:cond delay="4750"/>
+                                  </p:stCondLst>
+                                  <p:childTnLst>
+                                    <p:set>
+                                      <p:cBhvr>
+                                        <p:cTn id="61" dur="1" fill="hold">
+                                          <p:stCondLst>
+                                            <p:cond delay="0"/>
+                                          </p:stCondLst>
+                                        </p:cTn>
+                                        <p:tgtEl>
+                                          <p:spTgt spid="29"/>
+                                        </p:tgtEl>
+                                        <p:attrNameLst>
+                                          <p:attrName>style.visibility</p:attrName>
+                                        </p:attrNameLst>
+                                      </p:cBhvr>
+                                      <p:to>
+                                        <p:strVal val="visible"/>
+                                      </p:to>
+                                    </p:set>
+                                    <p:animEffect transition="in" filter="fade">
+                                      <p:cBhvr>
+                                        <p:cTn id="62" dur="400"/>
+                                        <p:tgtEl>
+                                          <p:spTgt spid="29"/>
+                                        </p:tgtEl>
+                                      </p:cBhvr>
+                                    </p:animEffect>
+                                  </p:childTnLst>
+                                </p:cTn>
+                              </p:par>
+                              <p:par>
+                                <p:cTn id="63" presetID="10" presetClass="entr" presetSubtype="0" fill="hold" grpId="0" nodeType="withEffect">
+                                  <p:stCondLst>
+                                    <p:cond delay="5000"/>
+                                  </p:stCondLst>
+                                  <p:childTnLst>
+                                    <p:set>
+                                      <p:cBhvr>
+                                        <p:cTn id="64" dur="1" fill="hold">
+                                          <p:stCondLst>
+                                            <p:cond delay="0"/>
+                                          </p:stCondLst>
+                                        </p:cTn>
+                                        <p:tgtEl>
+                                          <p:spTgt spid="30"/>
+                                        </p:tgtEl>
+                                        <p:attrNameLst>
+                                          <p:attrName>style.visibility</p:attrName>
+                                        </p:attrNameLst>
+                                      </p:cBhvr>
+                                      <p:to>
+                                        <p:strVal val="visible"/>
+                                      </p:to>
+                                    </p:set>
+                                    <p:animEffect transition="in" filter="fade">
+                                      <p:cBhvr>
+                                        <p:cTn id="65" dur="400"/>
+                                        <p:tgtEl>
+                                          <p:spTgt spid="30"/>
                                         </p:tgtEl>
                                       </p:cBhvr>
                                     </p:animEffect>

</xml_diff>

<commit_message>
docs(submission): roadmap cards fit at four columns
Co-Authored-By: Claude Fable 5.1 <noreply@anthropic.com>
</commit_message>
<xml_diff>
--- a/docs/submission/Kirana-Mitra-AI-Builder-Cup-Submission.pptx
+++ b/docs/submission/Kirana-Mitra-AI-Builder-Cup-Submission.pptx
@@ -5020,7 +5020,7 @@
                   <a:srgbClr val="1A1A1A"/>
                 </a:solidFill>
               </a:rPr>
-              <a:t>Sign-in and per-shop access (Firebase Auth) · real pilot sales and shelves · monitoring, rate limits and Gemini cost caps · backups and Firestore security rules · native review of the 22 languages.</a:t>
+              <a:t>Sign-in (Firebase Auth) · real pilot sales and shelves · monitoring, rate limits, Gemini cost caps · Firestore rules and backups.</a:t>
             </a:r>
             <a:endParaRPr lang="en-US" sz="850" dirty="0"/>
           </a:p>
@@ -5143,7 +5143,7 @@
                   <a:srgbClr val="1A1A1A"/>
                 </a:solidFill>
               </a:rPr>
-              <a:t>Backend already replies in all 22; the generated UI strings ship language by language after native-speaker review, largest eight first.</a:t>
+              <a:t>Backend replies in all 22 today; UI strings ship after native-speaker review, largest eight first.</a:t>
             </a:r>
             <a:endParaRPr lang="en-US" sz="850" dirty="0"/>
           </a:p>
@@ -5301,7 +5301,7 @@
       </p:sp>
       <p:pic>
         <p:nvPicPr>
-          <p:cNvPr id="24" name="anim Supply forecast &amp; WhatsApp icon" descr="preencoded.png">    </p:cNvPr>
+          <p:cNvPr id="24" name="anim Supply &amp; WhatsApp icon" descr="preencoded.png">    </p:cNvPr>
           <p:cNvPicPr>
             <a:picLocks noChangeAspect="1"/>
           </p:cNvPicPr>
@@ -5325,7 +5325,7 @@
       </p:pic>
       <p:sp>
         <p:nvSpPr>
-          <p:cNvPr id="25" name="anim Supply forecast &amp;amp; WhatsApp"/>
+          <p:cNvPr id="25" name="anim Supply &amp;amp; WhatsApp"/>
           <p:cNvSpPr txBox="1"/>
           <p:nvPr/>
         </p:nvSpPr>
@@ -5353,7 +5353,7 @@
                   <a:srgbClr val="1A1A1A"/>
                 </a:solidFill>
               </a:rPr>
-              <a:t>Supply forecast &amp; WhatsApp</a:t>
+              <a:t>Supply &amp; WhatsApp</a:t>
             </a:r>
             <a:endParaRPr lang="en-US" sz="1050" dirty="0"/>
           </a:p>
@@ -5361,7 +5361,7 @@
       </p:sp>
       <p:sp>
         <p:nvSpPr>
-          <p:cNvPr id="26" name="anim Supply forecast &amp;amp; WhatsApp text"/>
+          <p:cNvPr id="26" name="anim Supply &amp;amp; WhatsApp text"/>
           <p:cNvSpPr txBox="1"/>
           <p:nvPr/>
         </p:nvSpPr>

</xml_diff>

<commit_message>
docs(submission): deck links point to the team repository and the Drive video
Co-Authored-By: Claude Fable 5.1 <noreply@anthropic.com>
</commit_message>
<xml_diff>
--- a/docs/submission/Kirana-Mitra-AI-Builder-Cup-Submission.pptx
+++ b/docs/submission/Kirana-Mitra-AI-Builder-Cup-Submission.pptx
@@ -867,7 +867,7 @@
           <a:p>
             <a:r>
               <a:rPr lang="en-US" dirty="0"/>
-              <a:t>Make the repository public before submitting; it is private at the time of writing.</a:t>
+              <a:t>Repository: github.com/CuriousCoder2024/kirana-mitra. Video on Google Drive, 3:41.</a:t>
             </a:r>
             <a:endParaRPr lang="en-US" dirty="0"/>
           </a:p>
@@ -6520,7 +6520,7 @@
                   <a:srgbClr val="E8742B"/>
                 </a:solidFill>
               </a:rPr>
-              <a:t>github.com/vipindev-shambu/kirana-mitra</a:t>
+              <a:t>github.com/CuriousCoder2024/kirana-mitra</a:t>
             </a:r>
             <a:endParaRPr lang="en-US" sz="1000" dirty="0"/>
           </a:p>
@@ -6607,7 +6607,7 @@
                   <a:srgbClr val="1A1A1A"/>
                 </a:solidFill>
               </a:rPr>
-              <a:t>Demo video (3 minutes)</a:t>
+              <a:t>Demo video (3 min 41 s)</a:t>
             </a:r>
             <a:endParaRPr lang="en-US" sz="1100" dirty="0"/>
           </a:p>
@@ -6643,7 +6643,7 @@
                   <a:srgbClr val="E8742B"/>
                 </a:solidFill>
               </a:rPr>
-              <a:t>[video link]</a:t>
+              <a:t>drive.google.com/file/d/1STU9AMzXKyCT-jfIwJVH8B537z9enzrP/view</a:t>
             </a:r>
             <a:endParaRPr lang="en-US" sz="1000" dirty="0"/>
           </a:p>

</xml_diff>